<commit_message>
Lower minimum investment to ,000 across portal, PDFs, and PPTX deck
</commit_message>
<xml_diff>
--- a/public/docs/investors/ATLAS_Investor_Pitch_Deck.pptx
+++ b/public/docs/investors/ATLAS_Investor_Pitch_Deck.pptx
@@ -3215,7 +3215,7 @@
               </a:defRPr>
             </a:pPr>
             <a:r>
-              <a:t>Target Capital: $75,000 USD (YC Post-Money SAFE)  |  Valuation Cap: $1,750,000 USD (~4.29% Equity Cap)</a:t>
+              <a:t>Target Capital: $75,000 USD (YC Post-Money SAFE)  |  Valuation Cap: $1,750,000 USD  |  Min Check: $5,000</a:t>
             </a:r>
           </a:p>
           <a:p>
@@ -7476,7 +7476,7 @@
               </a:defRPr>
             </a:pPr>
             <a:r>
-              <a:t>$10,000 Angel Ticket</a:t>
+              <a:t>$5,000 Minimum Ticket</a:t>
             </a:r>
           </a:p>
           <a:p>
@@ -7491,7 +7491,7 @@
               </a:defRPr>
             </a:pPr>
             <a:r>
-              <a:t>• Implied Equity Cap: ~0.57%</a:t>
+              <a:t>• Implied Equity Cap: ~0.29%</a:t>
             </a:r>
           </a:p>
           <a:p>
@@ -7506,7 +7506,7 @@
               </a:defRPr>
             </a:pPr>
             <a:r>
-              <a:t>• Seed Round Markup: $86k–$114k (8.6x–11.4x paper markup in 12–15 mos)</a:t>
+              <a:t>• Seed Round Markup: $43k–$57k (8.6x–11.4x paper markup in 12–15 mos)</a:t>
             </a:r>
           </a:p>
           <a:p>
@@ -7521,7 +7521,7 @@
               </a:defRPr>
             </a:pPr>
             <a:r>
-              <a:t>• Base Case M&amp;A (Yr 3 @ $79M): $450,000+ in cash (45.2x return)</a:t>
+              <a:t>• Mid-Market M&amp;A (Yr 3 @ $60M): $171,000 in cash (34.3x return)</a:t>
             </a:r>
           </a:p>
           <a:p>
@@ -7536,7 +7536,7 @@
               </a:defRPr>
             </a:pPr>
             <a:r>
-              <a:t>• Growth Case M&amp;A (Yr 4 @ $538M): $3.06 Million in cash (307x return)</a:t>
+              <a:t>• Scale Buyout (Yr 4–5 @ $175M): $500,000 in cash (100x return)</a:t>
             </a:r>
           </a:p>
           <a:p>
@@ -7551,7 +7551,7 @@
               </a:defRPr>
             </a:pPr>
             <a:r>
-              <a:t>• Annual Cash Dividend (Yr 3): ~$75,000 / year (746% annual cash yield)</a:t>
+              <a:t>• Annual Cash Dividend (Yr 3): ~$37,500 / year (750% annual cash yield)</a:t>
             </a:r>
           </a:p>
         </p:txBody>
@@ -7631,7 +7631,7 @@
               </a:defRPr>
             </a:pPr>
             <a:r>
-              <a:t>$25,000 Lead Syndicate Ticket</a:t>
+              <a:t>$25,000 Recommended Check</a:t>
             </a:r>
           </a:p>
           <a:p>
@@ -7661,7 +7661,7 @@
               </a:defRPr>
             </a:pPr>
             <a:r>
-              <a:t>• Seed Round Markup: $215k–$286k (8.6x–11.4x paper markup)</a:t>
+              <a:t>• Seed Round Markup: $214k–$286k (8.6x–11.4x paper markup)</a:t>
             </a:r>
           </a:p>
           <a:p>
@@ -7676,7 +7676,7 @@
               </a:defRPr>
             </a:pPr>
             <a:r>
-              <a:t>• Base Case M&amp;A (Yr 3 @ $79M): $1.13 Million in cash (45.2x return)</a:t>
+              <a:t>• Mid-Market M&amp;A (Yr 3 @ $60M): $857,000 in cash (34.3x return)</a:t>
             </a:r>
           </a:p>
           <a:p>
@@ -7691,7 +7691,7 @@
               </a:defRPr>
             </a:pPr>
             <a:r>
-              <a:t>• Growth Case M&amp;A (Yr 4 @ $538M): $7.68 Million in cash (307x return)</a:t>
+              <a:t>• Scale Buyout (Yr 4–5 @ $175M): $2.50 Million in cash (100x return)</a:t>
             </a:r>
           </a:p>
           <a:p>
@@ -7706,7 +7706,7 @@
               </a:defRPr>
             </a:pPr>
             <a:r>
-              <a:t>• Annual Cash Dividend (Yr 3): ~$187,000 / year (749% annual cash yield)</a:t>
+              <a:t>• Annual Cash Dividend (Yr 3): ~$187,500 / year (750% annual cash yield)</a:t>
             </a:r>
           </a:p>
         </p:txBody>
@@ -7816,7 +7816,7 @@
               </a:defRPr>
             </a:pPr>
             <a:r>
-              <a:t>• Seed Round Markup: $644k–$858k (8.6x–11.4x paper markup)</a:t>
+              <a:t>• Seed Round Markup: $643k–$857k (8.6x–11.4x paper markup)</a:t>
             </a:r>
           </a:p>
           <a:p>
@@ -7831,7 +7831,7 @@
               </a:defRPr>
             </a:pPr>
             <a:r>
-              <a:t>• Base Case M&amp;A (Yr 3 @ $79M): $3.39 Million in cash (45.2x return)</a:t>
+              <a:t>• Mid-Market M&amp;A (Yr 3 @ $60M): $2.57 Million in cash (34.3x return)</a:t>
             </a:r>
           </a:p>
           <a:p>
@@ -7846,7 +7846,7 @@
               </a:defRPr>
             </a:pPr>
             <a:r>
-              <a:t>• Growth Case M&amp;A (Yr 4 @ $538M): $23.06 Million in cash (307x return)</a:t>
+              <a:t>• Scale Buyout (Yr 4–5 @ $175M): $7.50 Million in cash (100x return)</a:t>
             </a:r>
           </a:p>
           <a:p>
@@ -7861,7 +7861,7 @@
               </a:defRPr>
             </a:pPr>
             <a:r>
-              <a:t>• Annual Cash Dividend (Yr 3): ~$562,000 / year (749% annual cash yield)</a:t>
+              <a:t>• Annual Cash Dividend (Yr 3): ~$562,500 / year (750% annual cash yield)</a:t>
             </a:r>
           </a:p>
         </p:txBody>

</xml_diff>

<commit_message>
Add non-technical Development Phases and Timescale roadmap to Overview, Milestones, and PPTX deck
</commit_message>
<xml_diff>
--- a/public/docs/investors/ATLAS_Investor_Pitch_Deck.pptx
+++ b/public/docs/investors/ATLAS_Investor_Pitch_Deck.pptx
@@ -15,6 +15,7 @@
     <p:sldId id="263" r:id="rId14"/>
     <p:sldId id="264" r:id="rId15"/>
     <p:sldId id="265" r:id="rId16"/>
+    <p:sldId id="266" r:id="rId17"/>
   </p:sldIdLst>
   <p:sldSz cx="12191695" cy="6858000" type="screen4x3"/>
   <p:notesSz cx="6858000" cy="9144000"/>
@@ -3244,6 +3245,471 @@
 </file>
 
 <file path=ppt/slides/slide10.xml><?xml version="1.0" encoding="utf-8"?>
+<p:sld xmlns:a="http://schemas.openxmlformats.org/drawingml/2006/main" xmlns:p="http://schemas.openxmlformats.org/presentationml/2006/main" xmlns:r="http://schemas.openxmlformats.org/officeDocument/2006/relationships">
+  <p:cSld>
+    <p:spTree>
+      <p:nvGrpSpPr>
+        <p:cNvPr id="1" name=""/>
+        <p:cNvGrpSpPr/>
+        <p:nvPr/>
+      </p:nvGrpSpPr>
+      <p:grpSpPr/>
+      <p:sp>
+        <p:nvSpPr>
+          <p:cNvPr id="2" name="Rectangle 1"/>
+          <p:cNvSpPr/>
+          <p:nvPr/>
+        </p:nvSpPr>
+        <p:spPr>
+          <a:xfrm>
+            <a:off x="0" y="0"/>
+            <a:ext cx="12191695" cy="6858000"/>
+          </a:xfrm>
+          <a:prstGeom prst="rect">
+            <a:avLst/>
+          </a:prstGeom>
+          <a:solidFill>
+            <a:srgbClr val="0F172A"/>
+          </a:solidFill>
+          <a:ln>
+            <a:noFill/>
+          </a:ln>
+        </p:spPr>
+        <p:style>
+          <a:lnRef idx="1">
+            <a:schemeClr val="accent1"/>
+          </a:lnRef>
+          <a:fillRef idx="3">
+            <a:schemeClr val="accent1"/>
+          </a:fillRef>
+          <a:effectRef idx="2">
+            <a:schemeClr val="accent1"/>
+          </a:effectRef>
+          <a:fontRef idx="minor">
+            <a:schemeClr val="lt1"/>
+          </a:fontRef>
+        </p:style>
+        <p:txBody>
+          <a:bodyPr rtlCol="0" anchor="ctr"/>
+          <a:lstStyle/>
+          <a:p>
+            <a:pPr algn="ctr"/>
+          </a:p>
+        </p:txBody>
+      </p:sp>
+      <p:sp>
+        <p:nvSpPr>
+          <p:cNvPr id="3" name="TextBox 2"/>
+          <p:cNvSpPr txBox="1"/>
+          <p:nvPr/>
+        </p:nvSpPr>
+        <p:spPr>
+          <a:xfrm>
+            <a:off x="731520" y="457200"/>
+            <a:ext cx="10698480" cy="1280160"/>
+          </a:xfrm>
+          <a:prstGeom prst="rect">
+            <a:avLst/>
+          </a:prstGeom>
+          <a:noFill/>
+        </p:spPr>
+        <p:txBody>
+          <a:bodyPr wrap="square" lIns="0" tIns="0" rIns="0" bIns="0">
+            <a:spAutoFit/>
+          </a:bodyPr>
+          <a:lstStyle/>
+          <a:p>
+            <a:pPr>
+              <a:defRPr sz="1000" b="1">
+                <a:solidFill>
+                  <a:srgbClr val="F59E0B"/>
+                </a:solidFill>
+              </a:defRPr>
+            </a:pPr>
+            <a:r>
+              <a:t>LIQUIDITY OPTIONS</a:t>
+            </a:r>
+          </a:p>
+          <a:p>
+            <a:pPr>
+              <a:defRPr sz="2400" b="1">
+                <a:solidFill>
+                  <a:srgbClr val="FFFFFF"/>
+                </a:solidFill>
+              </a:defRPr>
+            </a:pPr>
+            <a:r>
+              <a:t>Strategic Buyer Universe &amp; Precedent Transactions</a:t>
+            </a:r>
+          </a:p>
+          <a:p>
+            <a:pPr>
+              <a:defRPr sz="1300">
+                <a:solidFill>
+                  <a:srgbClr val="94A3B8"/>
+                </a:solidFill>
+              </a:defRPr>
+            </a:pPr>
+            <a:r>
+              <a:t>Why premium card issuers, neo-banks, and global OTAs pay aggressive premiums.</a:t>
+            </a:r>
+          </a:p>
+        </p:txBody>
+      </p:sp>
+      <p:sp>
+        <p:nvSpPr>
+          <p:cNvPr id="4" name="Rounded Rectangle 3"/>
+          <p:cNvSpPr/>
+          <p:nvPr/>
+        </p:nvSpPr>
+        <p:spPr>
+          <a:xfrm>
+            <a:off x="731520" y="1920240"/>
+            <a:ext cx="3291840" cy="4206240"/>
+          </a:xfrm>
+          <a:prstGeom prst="roundRect">
+            <a:avLst/>
+          </a:prstGeom>
+          <a:solidFill>
+            <a:srgbClr val="1E293B"/>
+          </a:solidFill>
+          <a:ln w="12700">
+            <a:solidFill>
+              <a:srgbClr val="334155"/>
+            </a:solidFill>
+          </a:ln>
+        </p:spPr>
+        <p:style>
+          <a:lnRef idx="1">
+            <a:schemeClr val="accent1"/>
+          </a:lnRef>
+          <a:fillRef idx="3">
+            <a:schemeClr val="accent1"/>
+          </a:fillRef>
+          <a:effectRef idx="2">
+            <a:schemeClr val="accent1"/>
+          </a:effectRef>
+          <a:fontRef idx="minor">
+            <a:schemeClr val="lt1"/>
+          </a:fontRef>
+        </p:style>
+        <p:txBody>
+          <a:bodyPr rtlCol="0" anchor="ctr"/>
+          <a:lstStyle/>
+          <a:p>
+            <a:pPr algn="ctr"/>
+          </a:p>
+        </p:txBody>
+      </p:sp>
+      <p:sp>
+        <p:nvSpPr>
+          <p:cNvPr id="5" name="TextBox 4"/>
+          <p:cNvSpPr txBox="1"/>
+          <p:nvPr/>
+        </p:nvSpPr>
+        <p:spPr>
+          <a:xfrm>
+            <a:off x="1005840" y="2194560"/>
+            <a:ext cx="2743200" cy="3657600"/>
+          </a:xfrm>
+          <a:prstGeom prst="rect">
+            <a:avLst/>
+          </a:prstGeom>
+          <a:noFill/>
+        </p:spPr>
+        <p:txBody>
+          <a:bodyPr wrap="square" lIns="0" tIns="0" rIns="0" bIns="0">
+            <a:spAutoFit/>
+          </a:bodyPr>
+          <a:lstStyle/>
+          <a:p>
+            <a:pPr>
+              <a:defRPr sz="1500" b="1">
+                <a:solidFill>
+                  <a:srgbClr val="FFFFFF"/>
+                </a:solidFill>
+              </a:defRPr>
+            </a:pPr>
+            <a:r>
+              <a:t>Capital One / Velocity Black</a:t>
+            </a:r>
+          </a:p>
+          <a:p>
+            <a:pPr>
+              <a:spcBef>
+                <a:spcPts val="600"/>
+              </a:spcBef>
+              <a:defRPr sz="1100">
+                <a:solidFill>
+                  <a:srgbClr val="CBD5E1"/>
+                </a:solidFill>
+              </a:defRPr>
+            </a:pPr>
+            <a:r>
+              <a:t>• $297M Strategic Acquisition.</a:t>
+            </a:r>
+          </a:p>
+          <a:p>
+            <a:pPr>
+              <a:spcBef>
+                <a:spcPts val="600"/>
+              </a:spcBef>
+              <a:defRPr sz="1100">
+                <a:solidFill>
+                  <a:srgbClr val="CBD5E1"/>
+                </a:solidFill>
+              </a:defRPr>
+            </a:pPr>
+            <a:r>
+              <a:t>• Acquired to capture affluent consumer card spend and travel booking yield without paying OTA tolls.</a:t>
+            </a:r>
+          </a:p>
+          <a:p>
+            <a:pPr>
+              <a:spcBef>
+                <a:spcPts val="600"/>
+              </a:spcBef>
+              <a:defRPr sz="1100">
+                <a:solidFill>
+                  <a:srgbClr val="CBD5E1"/>
+                </a:solidFill>
+              </a:defRPr>
+            </a:pPr>
+            <a:r>
+              <a:t>• Validates high-net-worth membership model.</a:t>
+            </a:r>
+          </a:p>
+        </p:txBody>
+      </p:sp>
+      <p:sp>
+        <p:nvSpPr>
+          <p:cNvPr id="6" name="Rounded Rectangle 5"/>
+          <p:cNvSpPr/>
+          <p:nvPr/>
+        </p:nvSpPr>
+        <p:spPr>
+          <a:xfrm>
+            <a:off x="4389120" y="1920240"/>
+            <a:ext cx="3291840" cy="4206240"/>
+          </a:xfrm>
+          <a:prstGeom prst="roundRect">
+            <a:avLst/>
+          </a:prstGeom>
+          <a:solidFill>
+            <a:srgbClr val="1E293B"/>
+          </a:solidFill>
+          <a:ln w="12700">
+            <a:solidFill>
+              <a:srgbClr val="334155"/>
+            </a:solidFill>
+          </a:ln>
+        </p:spPr>
+        <p:style>
+          <a:lnRef idx="1">
+            <a:schemeClr val="accent1"/>
+          </a:lnRef>
+          <a:fillRef idx="3">
+            <a:schemeClr val="accent1"/>
+          </a:fillRef>
+          <a:effectRef idx="2">
+            <a:schemeClr val="accent1"/>
+          </a:effectRef>
+          <a:fontRef idx="minor">
+            <a:schemeClr val="lt1"/>
+          </a:fontRef>
+        </p:style>
+        <p:txBody>
+          <a:bodyPr rtlCol="0" anchor="ctr"/>
+          <a:lstStyle/>
+          <a:p>
+            <a:pPr algn="ctr"/>
+          </a:p>
+        </p:txBody>
+      </p:sp>
+      <p:sp>
+        <p:nvSpPr>
+          <p:cNvPr id="7" name="TextBox 6"/>
+          <p:cNvSpPr txBox="1"/>
+          <p:nvPr/>
+        </p:nvSpPr>
+        <p:spPr>
+          <a:xfrm>
+            <a:off x="4663440" y="2194560"/>
+            <a:ext cx="2743200" cy="3657600"/>
+          </a:xfrm>
+          <a:prstGeom prst="rect">
+            <a:avLst/>
+          </a:prstGeom>
+          <a:noFill/>
+        </p:spPr>
+        <p:txBody>
+          <a:bodyPr wrap="square" lIns="0" tIns="0" rIns="0" bIns="0">
+            <a:spAutoFit/>
+          </a:bodyPr>
+          <a:lstStyle/>
+          <a:p>
+            <a:pPr>
+              <a:defRPr sz="1500" b="1">
+                <a:solidFill>
+                  <a:srgbClr val="FFFFFF"/>
+                </a:solidFill>
+              </a:defRPr>
+            </a:pPr>
+            <a:r>
+              <a:t>JPMorgan Chase / Frosch</a:t>
+            </a:r>
+          </a:p>
+          <a:p>
+            <a:pPr>
+              <a:spcBef>
+                <a:spcPts val="600"/>
+              </a:spcBef>
+              <a:defRPr sz="1100">
+                <a:solidFill>
+                  <a:srgbClr val="CBD5E1"/>
+                </a:solidFill>
+              </a:defRPr>
+            </a:pPr>
+            <a:r>
+              <a:t>• Strategic Travel Asset Acquisition.</a:t>
+            </a:r>
+          </a:p>
+          <a:p>
+            <a:pPr>
+              <a:spcBef>
+                <a:spcPts val="600"/>
+              </a:spcBef>
+              <a:defRPr sz="1100">
+                <a:solidFill>
+                  <a:srgbClr val="CBD5E1"/>
+                </a:solidFill>
+              </a:defRPr>
+            </a:pPr>
+            <a:r>
+              <a:t>• Acquired luxury agency handling $1.5B+ in travel spend to internalize Sapphire Reserve cardholder margins.</a:t>
+            </a:r>
+          </a:p>
+        </p:txBody>
+      </p:sp>
+      <p:sp>
+        <p:nvSpPr>
+          <p:cNvPr id="8" name="Rounded Rectangle 7"/>
+          <p:cNvSpPr/>
+          <p:nvPr/>
+        </p:nvSpPr>
+        <p:spPr>
+          <a:xfrm>
+            <a:off x="8046720" y="1920240"/>
+            <a:ext cx="3291840" cy="4206240"/>
+          </a:xfrm>
+          <a:prstGeom prst="roundRect">
+            <a:avLst/>
+          </a:prstGeom>
+          <a:solidFill>
+            <a:srgbClr val="1E293B"/>
+          </a:solidFill>
+          <a:ln w="12700">
+            <a:solidFill>
+              <a:srgbClr val="334155"/>
+            </a:solidFill>
+          </a:ln>
+        </p:spPr>
+        <p:style>
+          <a:lnRef idx="1">
+            <a:schemeClr val="accent1"/>
+          </a:lnRef>
+          <a:fillRef idx="3">
+            <a:schemeClr val="accent1"/>
+          </a:fillRef>
+          <a:effectRef idx="2">
+            <a:schemeClr val="accent1"/>
+          </a:effectRef>
+          <a:fontRef idx="minor">
+            <a:schemeClr val="lt1"/>
+          </a:fontRef>
+        </p:style>
+        <p:txBody>
+          <a:bodyPr rtlCol="0" anchor="ctr"/>
+          <a:lstStyle/>
+          <a:p>
+            <a:pPr algn="ctr"/>
+          </a:p>
+        </p:txBody>
+      </p:sp>
+      <p:sp>
+        <p:nvSpPr>
+          <p:cNvPr id="9" name="TextBox 8"/>
+          <p:cNvSpPr txBox="1"/>
+          <p:nvPr/>
+        </p:nvSpPr>
+        <p:spPr>
+          <a:xfrm>
+            <a:off x="8321040" y="2194560"/>
+            <a:ext cx="2743200" cy="3657600"/>
+          </a:xfrm>
+          <a:prstGeom prst="rect">
+            <a:avLst/>
+          </a:prstGeom>
+          <a:noFill/>
+        </p:spPr>
+        <p:txBody>
+          <a:bodyPr wrap="square" lIns="0" tIns="0" rIns="0" bIns="0">
+            <a:spAutoFit/>
+          </a:bodyPr>
+          <a:lstStyle/>
+          <a:p>
+            <a:pPr>
+              <a:defRPr sz="1500" b="1">
+                <a:solidFill>
+                  <a:srgbClr val="FFFFFF"/>
+                </a:solidFill>
+              </a:defRPr>
+            </a:pPr>
+            <a:r>
+              <a:t>PE Dividend Recapitalization</a:t>
+            </a:r>
+          </a:p>
+          <a:p>
+            <a:pPr>
+              <a:spcBef>
+                <a:spcPts val="600"/>
+              </a:spcBef>
+              <a:defRPr sz="1100">
+                <a:solidFill>
+                  <a:srgbClr val="CBD5E1"/>
+                </a:solidFill>
+              </a:defRPr>
+            </a:pPr>
+            <a:r>
+              <a:t>• Asset-light high EBITDA allows buyout recapitalizations at 8x–12x EBITDA.</a:t>
+            </a:r>
+          </a:p>
+          <a:p>
+            <a:pPr>
+              <a:spcBef>
+                <a:spcPts val="600"/>
+              </a:spcBef>
+              <a:defRPr sz="1100">
+                <a:solidFill>
+                  <a:srgbClr val="CBD5E1"/>
+                </a:solidFill>
+              </a:defRPr>
+            </a:pPr>
+            <a:r>
+              <a:t>• Enables significant cash distributions to early angel investors without requiring an IPO.</a:t>
+            </a:r>
+          </a:p>
+        </p:txBody>
+      </p:sp>
+    </p:spTree>
+  </p:cSld>
+  <p:clrMapOvr>
+    <a:masterClrMapping/>
+  </p:clrMapOvr>
+</p:sld>
+</file>
+
+<file path=ppt/slides/slide11.xml><?xml version="1.0" encoding="utf-8"?>
 <p:sld xmlns:a="http://schemas.openxmlformats.org/drawingml/2006/main" xmlns:p="http://schemas.openxmlformats.org/presentationml/2006/main" xmlns:r="http://schemas.openxmlformats.org/officeDocument/2006/relationships">
   <p:cSld>
     <p:spTree>
@@ -7372,7 +7838,7 @@
               </a:defRPr>
             </a:pPr>
             <a:r>
-              <a:t>WHAT'S IN IT FOR YOU</a:t>
+              <a:t>COMMERCIAL EXECUTION</a:t>
             </a:r>
           </a:p>
           <a:p>
@@ -7384,7 +7850,7 @@
               </a:defRPr>
             </a:pPr>
             <a:r>
-              <a:t>Check Size Return Scenarios ($1.75M Valuation Cap)</a:t>
+              <a:t>Phases of Development &amp; Rollout Timescale</a:t>
             </a:r>
           </a:p>
           <a:p>
@@ -7396,7 +7862,7 @@
               </a:defRPr>
             </a:pPr>
             <a:r>
-              <a:t>Substantial financial upside across Series Seed markup, M&amp;A buyouts, and dividend yields.</a:t>
+              <a:t>Current Status: Month 4 (Platform Maturation &amp; Pilot) • 12-Month Path to 1,000 Members ($1.03M ARR).</a:t>
             </a:r>
           </a:p>
         </p:txBody>
@@ -7410,7 +7876,7 @@
         <p:spPr>
           <a:xfrm>
             <a:off x="731520" y="1920240"/>
-            <a:ext cx="3291840" cy="4206240"/>
+            <a:ext cx="2468880" cy="4297680"/>
           </a:xfrm>
           <a:prstGeom prst="roundRect">
             <a:avLst/>
@@ -7455,7 +7921,7 @@
         <p:spPr>
           <a:xfrm>
             <a:off x="1005840" y="2194560"/>
-            <a:ext cx="2743200" cy="3657600"/>
+            <a:ext cx="1920240" cy="3749040"/>
           </a:xfrm>
           <a:prstGeom prst="rect">
             <a:avLst/>
@@ -7476,82 +7942,86 @@
               </a:defRPr>
             </a:pPr>
             <a:r>
-              <a:t>$5,000 Minimum Ticket</a:t>
-            </a:r>
-          </a:p>
-          <a:p>
-            <a:pPr>
-              <a:spcBef>
-                <a:spcPts val="600"/>
-              </a:spcBef>
-              <a:defRPr sz="1100">
-                <a:solidFill>
-                  <a:srgbClr val="CBD5E1"/>
-                </a:solidFill>
-              </a:defRPr>
-            </a:pPr>
-            <a:r>
-              <a:t>• Implied Equity Cap: ~0.29%</a:t>
-            </a:r>
-          </a:p>
-          <a:p>
-            <a:pPr>
-              <a:spcBef>
-                <a:spcPts val="600"/>
-              </a:spcBef>
-              <a:defRPr sz="1100">
-                <a:solidFill>
-                  <a:srgbClr val="CBD5E1"/>
-                </a:solidFill>
-              </a:defRPr>
-            </a:pPr>
-            <a:r>
-              <a:t>• Seed Round Markup: $43k–$57k (8.6x–11.4x paper markup in 12–15 mos)</a:t>
-            </a:r>
-          </a:p>
-          <a:p>
-            <a:pPr>
-              <a:spcBef>
-                <a:spcPts val="600"/>
-              </a:spcBef>
-              <a:defRPr sz="1100">
-                <a:solidFill>
-                  <a:srgbClr val="CBD5E1"/>
-                </a:solidFill>
-              </a:defRPr>
-            </a:pPr>
-            <a:r>
-              <a:t>• Mid-Market M&amp;A (Yr 3 @ $60M): $171,000 in cash (34.3x return)</a:t>
-            </a:r>
-          </a:p>
-          <a:p>
-            <a:pPr>
-              <a:spcBef>
-                <a:spcPts val="600"/>
-              </a:spcBef>
-              <a:defRPr sz="1100">
-                <a:solidFill>
-                  <a:srgbClr val="CBD5E1"/>
-                </a:solidFill>
-              </a:defRPr>
-            </a:pPr>
-            <a:r>
-              <a:t>• Scale Buyout (Yr 4–5 @ $175M): $500,000 in cash (100x return)</a:t>
-            </a:r>
-          </a:p>
-          <a:p>
-            <a:pPr>
-              <a:spcBef>
-                <a:spcPts val="600"/>
-              </a:spcBef>
-              <a:defRPr sz="1100">
-                <a:solidFill>
-                  <a:srgbClr val="CBD5E1"/>
-                </a:solidFill>
-              </a:defRPr>
-            </a:pPr>
-            <a:r>
-              <a:t>• Annual Cash Dividend (Yr 3): ~$37,500 / year (750% annual cash yield)</a:t>
+              <a:t>Phase 1: Foundation</a:t>
+            </a:r>
+            <a:br/>
+            <a:r>
+              <a:t>(Months 1–3) • Done</a:t>
+            </a:r>
+          </a:p>
+          <a:p>
+            <a:pPr>
+              <a:spcBef>
+                <a:spcPts val="600"/>
+              </a:spcBef>
+              <a:defRPr sz="1100">
+                <a:solidFill>
+                  <a:srgbClr val="CBD5E1"/>
+                </a:solidFill>
+              </a:defRPr>
+            </a:pPr>
+            <a:r>
+              <a:t>• Status: 100% Completed</a:t>
+            </a:r>
+          </a:p>
+          <a:p>
+            <a:pPr>
+              <a:spcBef>
+                <a:spcPts val="600"/>
+              </a:spcBef>
+              <a:defRPr sz="1100">
+                <a:solidFill>
+                  <a:srgbClr val="CBD5E1"/>
+                </a:solidFill>
+              </a:defRPr>
+            </a:pPr>
+            <a:r>
+              <a:t>• Direct wholesale agreements secured across 650,000+ hotels.</a:t>
+            </a:r>
+          </a:p>
+          <a:p>
+            <a:pPr>
+              <a:spcBef>
+                <a:spcPts val="600"/>
+              </a:spcBef>
+              <a:defRPr sz="1100">
+                <a:solidFill>
+                  <a:srgbClr val="CBD5E1"/>
+                </a:solidFill>
+              </a:defRPr>
+            </a:pPr>
+            <a:r>
+              <a:t>• Zero-markup pricing engine &amp; rate comparison built.</a:t>
+            </a:r>
+          </a:p>
+          <a:p>
+            <a:pPr>
+              <a:spcBef>
+                <a:spcPts val="600"/>
+              </a:spcBef>
+              <a:defRPr sz="1100">
+                <a:solidFill>
+                  <a:srgbClr val="CBD5E1"/>
+                </a:solidFill>
+              </a:defRPr>
+            </a:pPr>
+            <a:r>
+              <a:t>• Manager-Managed LLC corporate entity formed.</a:t>
+            </a:r>
+          </a:p>
+          <a:p>
+            <a:pPr>
+              <a:spcBef>
+                <a:spcPts val="600"/>
+              </a:spcBef>
+              <a:defRPr sz="1100">
+                <a:solidFill>
+                  <a:srgbClr val="CBD5E1"/>
+                </a:solidFill>
+              </a:defRPr>
+            </a:pPr>
+            <a:r>
+              <a:t>• Negative working capital unit economics validated.</a:t>
             </a:r>
           </a:p>
         </p:txBody>
@@ -7564,8 +8034,8 @@
         </p:nvSpPr>
         <p:spPr>
           <a:xfrm>
-            <a:off x="4389120" y="1920240"/>
-            <a:ext cx="3291840" cy="4206240"/>
+            <a:off x="3474720" y="1920240"/>
+            <a:ext cx="2468880" cy="4297680"/>
           </a:xfrm>
           <a:prstGeom prst="roundRect">
             <a:avLst/>
@@ -7609,8 +8079,8 @@
         </p:nvSpPr>
         <p:spPr>
           <a:xfrm>
-            <a:off x="4663440" y="2194560"/>
-            <a:ext cx="2743200" cy="3657600"/>
+            <a:off x="3749040" y="2194560"/>
+            <a:ext cx="1920240" cy="3749040"/>
           </a:xfrm>
           <a:prstGeom prst="rect">
             <a:avLst/>
@@ -7631,82 +8101,86 @@
               </a:defRPr>
             </a:pPr>
             <a:r>
-              <a:t>$25,000 Recommended Check</a:t>
-            </a:r>
-          </a:p>
-          <a:p>
-            <a:pPr>
-              <a:spcBef>
-                <a:spcPts val="600"/>
-              </a:spcBef>
-              <a:defRPr sz="1100">
-                <a:solidFill>
-                  <a:srgbClr val="CBD5E1"/>
-                </a:solidFill>
-              </a:defRPr>
-            </a:pPr>
-            <a:r>
-              <a:t>• Implied Equity Cap: ~1.43%</a:t>
-            </a:r>
-          </a:p>
-          <a:p>
-            <a:pPr>
-              <a:spcBef>
-                <a:spcPts val="600"/>
-              </a:spcBef>
-              <a:defRPr sz="1100">
-                <a:solidFill>
-                  <a:srgbClr val="CBD5E1"/>
-                </a:solidFill>
-              </a:defRPr>
-            </a:pPr>
-            <a:r>
-              <a:t>• Seed Round Markup: $214k–$286k (8.6x–11.4x paper markup)</a:t>
-            </a:r>
-          </a:p>
-          <a:p>
-            <a:pPr>
-              <a:spcBef>
-                <a:spcPts val="600"/>
-              </a:spcBef>
-              <a:defRPr sz="1100">
-                <a:solidFill>
-                  <a:srgbClr val="CBD5E1"/>
-                </a:solidFill>
-              </a:defRPr>
-            </a:pPr>
-            <a:r>
-              <a:t>• Mid-Market M&amp;A (Yr 3 @ $60M): $857,000 in cash (34.3x return)</a:t>
-            </a:r>
-          </a:p>
-          <a:p>
-            <a:pPr>
-              <a:spcBef>
-                <a:spcPts val="600"/>
-              </a:spcBef>
-              <a:defRPr sz="1100">
-                <a:solidFill>
-                  <a:srgbClr val="CBD5E1"/>
-                </a:solidFill>
-              </a:defRPr>
-            </a:pPr>
-            <a:r>
-              <a:t>• Scale Buyout (Yr 4–5 @ $175M): $2.50 Million in cash (100x return)</a:t>
-            </a:r>
-          </a:p>
-          <a:p>
-            <a:pPr>
-              <a:spcBef>
-                <a:spcPts val="600"/>
-              </a:spcBef>
-              <a:defRPr sz="1100">
-                <a:solidFill>
-                  <a:srgbClr val="CBD5E1"/>
-                </a:solidFill>
-              </a:defRPr>
-            </a:pPr>
-            <a:r>
-              <a:t>• Annual Cash Dividend (Yr 3): ~$187,500 / year (750% annual cash yield)</a:t>
+              <a:t>Phase 2: Pilot Testing</a:t>
+            </a:r>
+            <a:br/>
+            <a:r>
+              <a:t>(Month 4) • Current</a:t>
+            </a:r>
+          </a:p>
+          <a:p>
+            <a:pPr>
+              <a:spcBef>
+                <a:spcPts val="600"/>
+              </a:spcBef>
+              <a:defRPr sz="1100">
+                <a:solidFill>
+                  <a:srgbClr val="CBD5E1"/>
+                </a:solidFill>
+              </a:defRPr>
+            </a:pPr>
+            <a:r>
+              <a:t>• Status: Active (You Are Here)</a:t>
+            </a:r>
+          </a:p>
+          <a:p>
+            <a:pPr>
+              <a:spcBef>
+                <a:spcPts val="600"/>
+              </a:spcBef>
+              <a:defRPr sz="1100">
+                <a:solidFill>
+                  <a:srgbClr val="CBD5E1"/>
+                </a:solidFill>
+              </a:defRPr>
+            </a:pPr>
+            <a:r>
+              <a:t>• Member search, room booking &amp; checkout flows operational.</a:t>
+            </a:r>
+          </a:p>
+          <a:p>
+            <a:pPr>
+              <a:spcBef>
+                <a:spcPts val="600"/>
+              </a:spcBef>
+              <a:defRPr sz="1100">
+                <a:solidFill>
+                  <a:srgbClr val="CBD5E1"/>
+                </a:solidFill>
+              </a:defRPr>
+            </a:pPr>
+            <a:r>
+              <a:t>• Real-world price audits confirm 30%–50% actual savings.</a:t>
+            </a:r>
+          </a:p>
+          <a:p>
+            <a:pPr>
+              <a:spcBef>
+                <a:spcPts val="600"/>
+              </a:spcBef>
+              <a:defRPr sz="1100">
+                <a:solidFill>
+                  <a:srgbClr val="CBD5E1"/>
+                </a:solidFill>
+              </a:defRPr>
+            </a:pPr>
+            <a:r>
+              <a:t>• Digital diligence room &amp; legal framework live.</a:t>
+            </a:r>
+          </a:p>
+          <a:p>
+            <a:pPr>
+              <a:spcBef>
+                <a:spcPts val="600"/>
+              </a:spcBef>
+              <a:defRPr sz="1100">
+                <a:solidFill>
+                  <a:srgbClr val="CBD5E1"/>
+                </a:solidFill>
+              </a:defRPr>
+            </a:pPr>
+            <a:r>
+              <a:t>• $75,000 SAFE round open ($5k min ticket) for pre-launch buffer.</a:t>
             </a:r>
           </a:p>
         </p:txBody>
@@ -7719,8 +8193,8 @@
         </p:nvSpPr>
         <p:spPr>
           <a:xfrm>
-            <a:off x="8046720" y="1920240"/>
-            <a:ext cx="3291840" cy="4206240"/>
+            <a:off x="6217920" y="1920240"/>
+            <a:ext cx="2468880" cy="4297680"/>
           </a:xfrm>
           <a:prstGeom prst="roundRect">
             <a:avLst/>
@@ -7764,8 +8238,8 @@
         </p:nvSpPr>
         <p:spPr>
           <a:xfrm>
-            <a:off x="8321040" y="2194560"/>
-            <a:ext cx="2743200" cy="3657600"/>
+            <a:off x="6492240" y="2194560"/>
+            <a:ext cx="1920240" cy="3749040"/>
           </a:xfrm>
           <a:prstGeom prst="rect">
             <a:avLst/>
@@ -7786,82 +8260,245 @@
               </a:defRPr>
             </a:pPr>
             <a:r>
-              <a:t>$75,000 Full Round Allocation</a:t>
-            </a:r>
-          </a:p>
-          <a:p>
-            <a:pPr>
-              <a:spcBef>
-                <a:spcPts val="600"/>
-              </a:spcBef>
-              <a:defRPr sz="1100">
-                <a:solidFill>
-                  <a:srgbClr val="CBD5E1"/>
-                </a:solidFill>
-              </a:defRPr>
-            </a:pPr>
-            <a:r>
-              <a:t>• Implied Equity Cap: ~4.29%</a:t>
-            </a:r>
-          </a:p>
-          <a:p>
-            <a:pPr>
-              <a:spcBef>
-                <a:spcPts val="600"/>
-              </a:spcBef>
-              <a:defRPr sz="1100">
-                <a:solidFill>
-                  <a:srgbClr val="CBD5E1"/>
-                </a:solidFill>
-              </a:defRPr>
-            </a:pPr>
-            <a:r>
-              <a:t>• Seed Round Markup: $643k–$857k (8.6x–11.4x paper markup)</a:t>
-            </a:r>
-          </a:p>
-          <a:p>
-            <a:pPr>
-              <a:spcBef>
-                <a:spcPts val="600"/>
-              </a:spcBef>
-              <a:defRPr sz="1100">
-                <a:solidFill>
-                  <a:srgbClr val="CBD5E1"/>
-                </a:solidFill>
-              </a:defRPr>
-            </a:pPr>
-            <a:r>
-              <a:t>• Mid-Market M&amp;A (Yr 3 @ $60M): $2.57 Million in cash (34.3x return)</a:t>
-            </a:r>
-          </a:p>
-          <a:p>
-            <a:pPr>
-              <a:spcBef>
-                <a:spcPts val="600"/>
-              </a:spcBef>
-              <a:defRPr sz="1100">
-                <a:solidFill>
-                  <a:srgbClr val="CBD5E1"/>
-                </a:solidFill>
-              </a:defRPr>
-            </a:pPr>
-            <a:r>
-              <a:t>• Scale Buyout (Yr 4–5 @ $175M): $7.50 Million in cash (100x return)</a:t>
-            </a:r>
-          </a:p>
-          <a:p>
-            <a:pPr>
-              <a:spcBef>
-                <a:spcPts val="600"/>
-              </a:spcBef>
-              <a:defRPr sz="1100">
-                <a:solidFill>
-                  <a:srgbClr val="CBD5E1"/>
-                </a:solidFill>
-              </a:defRPr>
-            </a:pPr>
-            <a:r>
-              <a:t>• Annual Cash Dividend (Yr 3): ~$562,500 / year (750% annual cash yield)</a:t>
+              <a:t>Phase 3: Beta &amp; 100 Mbrs</a:t>
+            </a:r>
+            <a:br/>
+            <a:r>
+              <a:t>(Months 5–6) • Upcoming</a:t>
+            </a:r>
+          </a:p>
+          <a:p>
+            <a:pPr>
+              <a:spcBef>
+                <a:spcPts val="600"/>
+              </a:spcBef>
+              <a:defRPr sz="1100">
+                <a:solidFill>
+                  <a:srgbClr val="CBD5E1"/>
+                </a:solidFill>
+              </a:defRPr>
+            </a:pPr>
+            <a:r>
+              <a:t>• Status: Next 60 Days (Q2)</a:t>
+            </a:r>
+          </a:p>
+          <a:p>
+            <a:pPr>
+              <a:spcBef>
+                <a:spcPts val="600"/>
+              </a:spcBef>
+              <a:defRPr sz="1100">
+                <a:solidFill>
+                  <a:srgbClr val="CBD5E1"/>
+                </a:solidFill>
+              </a:defRPr>
+            </a:pPr>
+            <a:r>
+              <a:t>• Onboarding first 100 private founding members by invitation.</a:t>
+            </a:r>
+          </a:p>
+          <a:p>
+            <a:pPr>
+              <a:spcBef>
+                <a:spcPts val="600"/>
+              </a:spcBef>
+              <a:defRPr sz="1100">
+                <a:solidFill>
+                  <a:srgbClr val="CBD5E1"/>
+                </a:solidFill>
+              </a:defRPr>
+            </a:pPr>
+            <a:r>
+              <a:t>• Live bookings executed with 24/7 VIP concierge check-in.</a:t>
+            </a:r>
+          </a:p>
+          <a:p>
+            <a:pPr>
+              <a:spcBef>
+                <a:spcPts val="600"/>
+              </a:spcBef>
+              <a:defRPr sz="1100">
+                <a:solidFill>
+                  <a:srgbClr val="CBD5E1"/>
+                </a:solidFill>
+              </a:defRPr>
+            </a:pPr>
+            <a:r>
+              <a:t>• Activation of referral program ('Give $100, Get $100').</a:t>
+            </a:r>
+          </a:p>
+          <a:p>
+            <a:pPr>
+              <a:spcBef>
+                <a:spcPts val="600"/>
+              </a:spcBef>
+              <a:defRPr sz="1100">
+                <a:solidFill>
+                  <a:srgbClr val="CBD5E1"/>
+                </a:solidFill>
+              </a:defRPr>
+            </a:pPr>
+            <a:r>
+              <a:t>• Refine booking conversion &amp; collect verified reviews.</a:t>
+            </a:r>
+          </a:p>
+        </p:txBody>
+      </p:sp>
+      <p:sp>
+        <p:nvSpPr>
+          <p:cNvPr id="10" name="Rounded Rectangle 9"/>
+          <p:cNvSpPr/>
+          <p:nvPr/>
+        </p:nvSpPr>
+        <p:spPr>
+          <a:xfrm>
+            <a:off x="8961120" y="1920240"/>
+            <a:ext cx="2468880" cy="4297680"/>
+          </a:xfrm>
+          <a:prstGeom prst="roundRect">
+            <a:avLst/>
+          </a:prstGeom>
+          <a:solidFill>
+            <a:srgbClr val="1E293B"/>
+          </a:solidFill>
+          <a:ln w="12700">
+            <a:solidFill>
+              <a:srgbClr val="334155"/>
+            </a:solidFill>
+          </a:ln>
+        </p:spPr>
+        <p:style>
+          <a:lnRef idx="1">
+            <a:schemeClr val="accent1"/>
+          </a:lnRef>
+          <a:fillRef idx="3">
+            <a:schemeClr val="accent1"/>
+          </a:fillRef>
+          <a:effectRef idx="2">
+            <a:schemeClr val="accent1"/>
+          </a:effectRef>
+          <a:fontRef idx="minor">
+            <a:schemeClr val="lt1"/>
+          </a:fontRef>
+        </p:style>
+        <p:txBody>
+          <a:bodyPr rtlCol="0" anchor="ctr"/>
+          <a:lstStyle/>
+          <a:p>
+            <a:pPr algn="ctr"/>
+          </a:p>
+        </p:txBody>
+      </p:sp>
+      <p:sp>
+        <p:nvSpPr>
+          <p:cNvPr id="11" name="TextBox 10"/>
+          <p:cNvSpPr txBox="1"/>
+          <p:nvPr/>
+        </p:nvSpPr>
+        <p:spPr>
+          <a:xfrm>
+            <a:off x="9235440" y="2194560"/>
+            <a:ext cx="1920240" cy="3749040"/>
+          </a:xfrm>
+          <a:prstGeom prst="rect">
+            <a:avLst/>
+          </a:prstGeom>
+          <a:noFill/>
+        </p:spPr>
+        <p:txBody>
+          <a:bodyPr wrap="square" lIns="0" tIns="0" rIns="0" bIns="0">
+            <a:spAutoFit/>
+          </a:bodyPr>
+          <a:lstStyle/>
+          <a:p>
+            <a:pPr>
+              <a:defRPr sz="1500" b="1">
+                <a:solidFill>
+                  <a:srgbClr val="FFFFFF"/>
+                </a:solidFill>
+              </a:defRPr>
+            </a:pPr>
+            <a:r>
+              <a:t>Phase 4: Scale to 1k</a:t>
+            </a:r>
+            <a:br/>
+            <a:r>
+              <a:t>(Months 7–12) • Expansion</a:t>
+            </a:r>
+          </a:p>
+          <a:p>
+            <a:pPr>
+              <a:spcBef>
+                <a:spcPts val="600"/>
+              </a:spcBef>
+              <a:defRPr sz="1100">
+                <a:solidFill>
+                  <a:srgbClr val="CBD5E1"/>
+                </a:solidFill>
+              </a:defRPr>
+            </a:pPr>
+            <a:r>
+              <a:t>• Status: Target Scale (Q3–Q4)</a:t>
+            </a:r>
+          </a:p>
+          <a:p>
+            <a:pPr>
+              <a:spcBef>
+                <a:spcPts val="600"/>
+              </a:spcBef>
+              <a:defRPr sz="1100">
+                <a:solidFill>
+                  <a:srgbClr val="CBD5E1"/>
+                </a:solidFill>
+              </a:defRPr>
+            </a:pPr>
+            <a:r>
+              <a:t>• Commercial launch across key European and US business hubs.</a:t>
+            </a:r>
+          </a:p>
+          <a:p>
+            <a:pPr>
+              <a:spcBef>
+                <a:spcPts val="600"/>
+              </a:spcBef>
+              <a:defRPr sz="1100">
+                <a:solidFill>
+                  <a:srgbClr val="CBD5E1"/>
+                </a:solidFill>
+              </a:defRPr>
+            </a:pPr>
+            <a:r>
+              <a:t>• Executive club and corporate travel partnerships.</a:t>
+            </a:r>
+          </a:p>
+          <a:p>
+            <a:pPr>
+              <a:spcBef>
+                <a:spcPts val="600"/>
+              </a:spcBef>
+              <a:defRPr sz="1100">
+                <a:solidFill>
+                  <a:srgbClr val="CBD5E1"/>
+                </a:solidFill>
+              </a:defRPr>
+            </a:pPr>
+            <a:r>
+              <a:t>• Scale to 1,000 paying members ($1.03M ARR, cash-flow breakeven).</a:t>
+            </a:r>
+          </a:p>
+          <a:p>
+            <a:pPr>
+              <a:spcBef>
+                <a:spcPts val="600"/>
+              </a:spcBef>
+              <a:defRPr sz="1100">
+                <a:solidFill>
+                  <a:srgbClr val="CBD5E1"/>
+                </a:solidFill>
+              </a:defRPr>
+            </a:pPr>
+            <a:r>
+              <a:t>• Series Seed institutional financing ($15M–$20M valuation).</a:t>
             </a:r>
           </a:p>
         </p:txBody>
@@ -7957,7 +8594,7 @@
               </a:defRPr>
             </a:pPr>
             <a:r>
-              <a:t>LIQUIDITY OPTIONS</a:t>
+              <a:t>WHAT'S IN IT FOR YOU</a:t>
             </a:r>
           </a:p>
           <a:p>
@@ -7969,7 +8606,7 @@
               </a:defRPr>
             </a:pPr>
             <a:r>
-              <a:t>Strategic Buyer Universe &amp; Precedent Transactions</a:t>
+              <a:t>Check Size Return Scenarios ($1.75M Valuation Cap)</a:t>
             </a:r>
           </a:p>
           <a:p>
@@ -7981,7 +8618,7 @@
               </a:defRPr>
             </a:pPr>
             <a:r>
-              <a:t>Why premium card issuers, neo-banks, and global OTAs pay aggressive premiums.</a:t>
+              <a:t>Substantial financial upside across Series Seed markup, M&amp;A buyouts, and dividend yields.</a:t>
             </a:r>
           </a:p>
         </p:txBody>
@@ -8061,52 +8698,82 @@
               </a:defRPr>
             </a:pPr>
             <a:r>
-              <a:t>Capital One / Velocity Black</a:t>
-            </a:r>
-          </a:p>
-          <a:p>
-            <a:pPr>
-              <a:spcBef>
-                <a:spcPts val="600"/>
-              </a:spcBef>
-              <a:defRPr sz="1100">
-                <a:solidFill>
-                  <a:srgbClr val="CBD5E1"/>
-                </a:solidFill>
-              </a:defRPr>
-            </a:pPr>
-            <a:r>
-              <a:t>• $297M Strategic Acquisition.</a:t>
-            </a:r>
-          </a:p>
-          <a:p>
-            <a:pPr>
-              <a:spcBef>
-                <a:spcPts val="600"/>
-              </a:spcBef>
-              <a:defRPr sz="1100">
-                <a:solidFill>
-                  <a:srgbClr val="CBD5E1"/>
-                </a:solidFill>
-              </a:defRPr>
-            </a:pPr>
-            <a:r>
-              <a:t>• Acquired to capture affluent consumer card spend and travel booking yield without paying OTA tolls.</a:t>
-            </a:r>
-          </a:p>
-          <a:p>
-            <a:pPr>
-              <a:spcBef>
-                <a:spcPts val="600"/>
-              </a:spcBef>
-              <a:defRPr sz="1100">
-                <a:solidFill>
-                  <a:srgbClr val="CBD5E1"/>
-                </a:solidFill>
-              </a:defRPr>
-            </a:pPr>
-            <a:r>
-              <a:t>• Validates high-net-worth membership model.</a:t>
+              <a:t>$5,000 Minimum Ticket</a:t>
+            </a:r>
+          </a:p>
+          <a:p>
+            <a:pPr>
+              <a:spcBef>
+                <a:spcPts val="600"/>
+              </a:spcBef>
+              <a:defRPr sz="1100">
+                <a:solidFill>
+                  <a:srgbClr val="CBD5E1"/>
+                </a:solidFill>
+              </a:defRPr>
+            </a:pPr>
+            <a:r>
+              <a:t>• Implied Equity Cap: ~0.29%</a:t>
+            </a:r>
+          </a:p>
+          <a:p>
+            <a:pPr>
+              <a:spcBef>
+                <a:spcPts val="600"/>
+              </a:spcBef>
+              <a:defRPr sz="1100">
+                <a:solidFill>
+                  <a:srgbClr val="CBD5E1"/>
+                </a:solidFill>
+              </a:defRPr>
+            </a:pPr>
+            <a:r>
+              <a:t>• Seed Round Markup: $43k–$57k (8.6x–11.4x paper markup in 12–15 mos)</a:t>
+            </a:r>
+          </a:p>
+          <a:p>
+            <a:pPr>
+              <a:spcBef>
+                <a:spcPts val="600"/>
+              </a:spcBef>
+              <a:defRPr sz="1100">
+                <a:solidFill>
+                  <a:srgbClr val="CBD5E1"/>
+                </a:solidFill>
+              </a:defRPr>
+            </a:pPr>
+            <a:r>
+              <a:t>• Mid-Market M&amp;A (Yr 3 @ $60M): $171,000 in cash (34.3x return)</a:t>
+            </a:r>
+          </a:p>
+          <a:p>
+            <a:pPr>
+              <a:spcBef>
+                <a:spcPts val="600"/>
+              </a:spcBef>
+              <a:defRPr sz="1100">
+                <a:solidFill>
+                  <a:srgbClr val="CBD5E1"/>
+                </a:solidFill>
+              </a:defRPr>
+            </a:pPr>
+            <a:r>
+              <a:t>• Scale Buyout (Yr 4–5 @ $175M): $500,000 in cash (100x return)</a:t>
+            </a:r>
+          </a:p>
+          <a:p>
+            <a:pPr>
+              <a:spcBef>
+                <a:spcPts val="600"/>
+              </a:spcBef>
+              <a:defRPr sz="1100">
+                <a:solidFill>
+                  <a:srgbClr val="CBD5E1"/>
+                </a:solidFill>
+              </a:defRPr>
+            </a:pPr>
+            <a:r>
+              <a:t>• Annual Cash Dividend (Yr 3): ~$37,500 / year (750% annual cash yield)</a:t>
             </a:r>
           </a:p>
         </p:txBody>
@@ -8120,6 +8787,161 @@
         <p:spPr>
           <a:xfrm>
             <a:off x="4389120" y="1920240"/>
+            <a:ext cx="3291840" cy="4206240"/>
+          </a:xfrm>
+          <a:prstGeom prst="roundRect">
+            <a:avLst/>
+          </a:prstGeom>
+          <a:solidFill>
+            <a:srgbClr val="1E293B"/>
+          </a:solidFill>
+          <a:ln w="19050">
+            <a:solidFill>
+              <a:srgbClr val="F59E0B"/>
+            </a:solidFill>
+          </a:ln>
+        </p:spPr>
+        <p:style>
+          <a:lnRef idx="1">
+            <a:schemeClr val="accent1"/>
+          </a:lnRef>
+          <a:fillRef idx="3">
+            <a:schemeClr val="accent1"/>
+          </a:fillRef>
+          <a:effectRef idx="2">
+            <a:schemeClr val="accent1"/>
+          </a:effectRef>
+          <a:fontRef idx="minor">
+            <a:schemeClr val="lt1"/>
+          </a:fontRef>
+        </p:style>
+        <p:txBody>
+          <a:bodyPr rtlCol="0" anchor="ctr"/>
+          <a:lstStyle/>
+          <a:p>
+            <a:pPr algn="ctr"/>
+          </a:p>
+        </p:txBody>
+      </p:sp>
+      <p:sp>
+        <p:nvSpPr>
+          <p:cNvPr id="7" name="TextBox 6"/>
+          <p:cNvSpPr txBox="1"/>
+          <p:nvPr/>
+        </p:nvSpPr>
+        <p:spPr>
+          <a:xfrm>
+            <a:off x="4663440" y="2194560"/>
+            <a:ext cx="2743200" cy="3657600"/>
+          </a:xfrm>
+          <a:prstGeom prst="rect">
+            <a:avLst/>
+          </a:prstGeom>
+          <a:noFill/>
+        </p:spPr>
+        <p:txBody>
+          <a:bodyPr wrap="square" lIns="0" tIns="0" rIns="0" bIns="0">
+            <a:spAutoFit/>
+          </a:bodyPr>
+          <a:lstStyle/>
+          <a:p>
+            <a:pPr>
+              <a:defRPr sz="1500" b="1">
+                <a:solidFill>
+                  <a:srgbClr val="F59E0B"/>
+                </a:solidFill>
+              </a:defRPr>
+            </a:pPr>
+            <a:r>
+              <a:t>$25,000 Recommended Check</a:t>
+            </a:r>
+          </a:p>
+          <a:p>
+            <a:pPr>
+              <a:spcBef>
+                <a:spcPts val="600"/>
+              </a:spcBef>
+              <a:defRPr sz="1100">
+                <a:solidFill>
+                  <a:srgbClr val="CBD5E1"/>
+                </a:solidFill>
+              </a:defRPr>
+            </a:pPr>
+            <a:r>
+              <a:t>• Implied Equity Cap: ~1.43%</a:t>
+            </a:r>
+          </a:p>
+          <a:p>
+            <a:pPr>
+              <a:spcBef>
+                <a:spcPts val="600"/>
+              </a:spcBef>
+              <a:defRPr sz="1100">
+                <a:solidFill>
+                  <a:srgbClr val="CBD5E1"/>
+                </a:solidFill>
+              </a:defRPr>
+            </a:pPr>
+            <a:r>
+              <a:t>• Seed Round Markup: $214k–$286k (8.6x–11.4x paper markup)</a:t>
+            </a:r>
+          </a:p>
+          <a:p>
+            <a:pPr>
+              <a:spcBef>
+                <a:spcPts val="600"/>
+              </a:spcBef>
+              <a:defRPr sz="1100">
+                <a:solidFill>
+                  <a:srgbClr val="CBD5E1"/>
+                </a:solidFill>
+              </a:defRPr>
+            </a:pPr>
+            <a:r>
+              <a:t>• Mid-Market M&amp;A (Yr 3 @ $60M): $857,000 in cash (34.3x return)</a:t>
+            </a:r>
+          </a:p>
+          <a:p>
+            <a:pPr>
+              <a:spcBef>
+                <a:spcPts val="600"/>
+              </a:spcBef>
+              <a:defRPr sz="1100">
+                <a:solidFill>
+                  <a:srgbClr val="CBD5E1"/>
+                </a:solidFill>
+              </a:defRPr>
+            </a:pPr>
+            <a:r>
+              <a:t>• Scale Buyout (Yr 4–5 @ $175M): $2.50 Million in cash (100x return)</a:t>
+            </a:r>
+          </a:p>
+          <a:p>
+            <a:pPr>
+              <a:spcBef>
+                <a:spcPts val="600"/>
+              </a:spcBef>
+              <a:defRPr sz="1100">
+                <a:solidFill>
+                  <a:srgbClr val="CBD5E1"/>
+                </a:solidFill>
+              </a:defRPr>
+            </a:pPr>
+            <a:r>
+              <a:t>• Annual Cash Dividend (Yr 3): ~$187,500 / year (750% annual cash yield)</a:t>
+            </a:r>
+          </a:p>
+        </p:txBody>
+      </p:sp>
+      <p:sp>
+        <p:nvSpPr>
+          <p:cNvPr id="8" name="Rounded Rectangle 7"/>
+          <p:cNvSpPr/>
+          <p:nvPr/>
+        </p:nvSpPr>
+        <p:spPr>
+          <a:xfrm>
+            <a:off x="8046720" y="1920240"/>
             <a:ext cx="3291840" cy="4206240"/>
           </a:xfrm>
           <a:prstGeom prst="roundRect">
@@ -8158,13 +8980,13 @@
       </p:sp>
       <p:sp>
         <p:nvSpPr>
-          <p:cNvPr id="7" name="TextBox 6"/>
+          <p:cNvPr id="9" name="TextBox 8"/>
           <p:cNvSpPr txBox="1"/>
           <p:nvPr/>
         </p:nvSpPr>
         <p:spPr>
           <a:xfrm>
-            <a:off x="4663440" y="2194560"/>
+            <a:off x="8321040" y="2194560"/>
             <a:ext cx="2743200" cy="3657600"/>
           </a:xfrm>
           <a:prstGeom prst="rect">
@@ -8186,147 +9008,82 @@
               </a:defRPr>
             </a:pPr>
             <a:r>
-              <a:t>JPMorgan Chase / Frosch</a:t>
-            </a:r>
-          </a:p>
-          <a:p>
-            <a:pPr>
-              <a:spcBef>
-                <a:spcPts val="600"/>
-              </a:spcBef>
-              <a:defRPr sz="1100">
-                <a:solidFill>
-                  <a:srgbClr val="CBD5E1"/>
-                </a:solidFill>
-              </a:defRPr>
-            </a:pPr>
-            <a:r>
-              <a:t>• Strategic Travel Asset Acquisition.</a:t>
-            </a:r>
-          </a:p>
-          <a:p>
-            <a:pPr>
-              <a:spcBef>
-                <a:spcPts val="600"/>
-              </a:spcBef>
-              <a:defRPr sz="1100">
-                <a:solidFill>
-                  <a:srgbClr val="CBD5E1"/>
-                </a:solidFill>
-              </a:defRPr>
-            </a:pPr>
-            <a:r>
-              <a:t>• Acquired luxury agency handling $1.5B+ in travel spend to internalize Sapphire Reserve cardholder margins.</a:t>
-            </a:r>
-          </a:p>
-        </p:txBody>
-      </p:sp>
-      <p:sp>
-        <p:nvSpPr>
-          <p:cNvPr id="8" name="Rounded Rectangle 7"/>
-          <p:cNvSpPr/>
-          <p:nvPr/>
-        </p:nvSpPr>
-        <p:spPr>
-          <a:xfrm>
-            <a:off x="8046720" y="1920240"/>
-            <a:ext cx="3291840" cy="4206240"/>
-          </a:xfrm>
-          <a:prstGeom prst="roundRect">
-            <a:avLst/>
-          </a:prstGeom>
-          <a:solidFill>
-            <a:srgbClr val="1E293B"/>
-          </a:solidFill>
-          <a:ln w="12700">
-            <a:solidFill>
-              <a:srgbClr val="334155"/>
-            </a:solidFill>
-          </a:ln>
-        </p:spPr>
-        <p:style>
-          <a:lnRef idx="1">
-            <a:schemeClr val="accent1"/>
-          </a:lnRef>
-          <a:fillRef idx="3">
-            <a:schemeClr val="accent1"/>
-          </a:fillRef>
-          <a:effectRef idx="2">
-            <a:schemeClr val="accent1"/>
-          </a:effectRef>
-          <a:fontRef idx="minor">
-            <a:schemeClr val="lt1"/>
-          </a:fontRef>
-        </p:style>
-        <p:txBody>
-          <a:bodyPr rtlCol="0" anchor="ctr"/>
-          <a:lstStyle/>
-          <a:p>
-            <a:pPr algn="ctr"/>
-          </a:p>
-        </p:txBody>
-      </p:sp>
-      <p:sp>
-        <p:nvSpPr>
-          <p:cNvPr id="9" name="TextBox 8"/>
-          <p:cNvSpPr txBox="1"/>
-          <p:nvPr/>
-        </p:nvSpPr>
-        <p:spPr>
-          <a:xfrm>
-            <a:off x="8321040" y="2194560"/>
-            <a:ext cx="2743200" cy="3657600"/>
-          </a:xfrm>
-          <a:prstGeom prst="rect">
-            <a:avLst/>
-          </a:prstGeom>
-          <a:noFill/>
-        </p:spPr>
-        <p:txBody>
-          <a:bodyPr wrap="square" lIns="0" tIns="0" rIns="0" bIns="0">
-            <a:spAutoFit/>
-          </a:bodyPr>
-          <a:lstStyle/>
-          <a:p>
-            <a:pPr>
-              <a:defRPr sz="1500" b="1">
-                <a:solidFill>
-                  <a:srgbClr val="FFFFFF"/>
-                </a:solidFill>
-              </a:defRPr>
-            </a:pPr>
-            <a:r>
-              <a:t>PE Dividend Recapitalization</a:t>
-            </a:r>
-          </a:p>
-          <a:p>
-            <a:pPr>
-              <a:spcBef>
-                <a:spcPts val="600"/>
-              </a:spcBef>
-              <a:defRPr sz="1100">
-                <a:solidFill>
-                  <a:srgbClr val="CBD5E1"/>
-                </a:solidFill>
-              </a:defRPr>
-            </a:pPr>
-            <a:r>
-              <a:t>• Asset-light high EBITDA allows buyout recapitalizations at 8x–12x EBITDA.</a:t>
-            </a:r>
-          </a:p>
-          <a:p>
-            <a:pPr>
-              <a:spcBef>
-                <a:spcPts val="600"/>
-              </a:spcBef>
-              <a:defRPr sz="1100">
-                <a:solidFill>
-                  <a:srgbClr val="CBD5E1"/>
-                </a:solidFill>
-              </a:defRPr>
-            </a:pPr>
-            <a:r>
-              <a:t>• Enables significant cash distributions to early angel investors without requiring an IPO.</a:t>
+              <a:t>$75,000 Full Round Allocation</a:t>
+            </a:r>
+          </a:p>
+          <a:p>
+            <a:pPr>
+              <a:spcBef>
+                <a:spcPts val="600"/>
+              </a:spcBef>
+              <a:defRPr sz="1100">
+                <a:solidFill>
+                  <a:srgbClr val="CBD5E1"/>
+                </a:solidFill>
+              </a:defRPr>
+            </a:pPr>
+            <a:r>
+              <a:t>• Implied Equity Cap: ~4.29%</a:t>
+            </a:r>
+          </a:p>
+          <a:p>
+            <a:pPr>
+              <a:spcBef>
+                <a:spcPts val="600"/>
+              </a:spcBef>
+              <a:defRPr sz="1100">
+                <a:solidFill>
+                  <a:srgbClr val="CBD5E1"/>
+                </a:solidFill>
+              </a:defRPr>
+            </a:pPr>
+            <a:r>
+              <a:t>• Seed Round Markup: $643k–$857k (8.6x–11.4x paper markup)</a:t>
+            </a:r>
+          </a:p>
+          <a:p>
+            <a:pPr>
+              <a:spcBef>
+                <a:spcPts val="600"/>
+              </a:spcBef>
+              <a:defRPr sz="1100">
+                <a:solidFill>
+                  <a:srgbClr val="CBD5E1"/>
+                </a:solidFill>
+              </a:defRPr>
+            </a:pPr>
+            <a:r>
+              <a:t>• Mid-Market M&amp;A (Yr 3 @ $60M): $2.57 Million in cash (34.3x return)</a:t>
+            </a:r>
+          </a:p>
+          <a:p>
+            <a:pPr>
+              <a:spcBef>
+                <a:spcPts val="600"/>
+              </a:spcBef>
+              <a:defRPr sz="1100">
+                <a:solidFill>
+                  <a:srgbClr val="CBD5E1"/>
+                </a:solidFill>
+              </a:defRPr>
+            </a:pPr>
+            <a:r>
+              <a:t>• Scale Buyout (Yr 4–5 @ $175M): $7.50 Million in cash (100x return)</a:t>
+            </a:r>
+          </a:p>
+          <a:p>
+            <a:pPr>
+              <a:spcBef>
+                <a:spcPts val="600"/>
+              </a:spcBef>
+              <a:defRPr sz="1100">
+                <a:solidFill>
+                  <a:srgbClr val="CBD5E1"/>
+                </a:solidFill>
+              </a:defRPr>
+            </a:pPr>
+            <a:r>
+              <a:t>• Annual Cash Dividend (Yr 3): ~$562,500 / year (750% annual cash yield)</a:t>
             </a:r>
           </a:p>
         </p:txBody>

</xml_diff>

<commit_message>
Add comprehensive explanation of Price Parity, the Closed-Loop Safe Harbor, and the OTA economic moat
</commit_message>
<xml_diff>
--- a/public/docs/investors/ATLAS_Investor_Pitch_Deck.pptx
+++ b/public/docs/investors/ATLAS_Investor_Pitch_Deck.pptx
@@ -4436,52 +4436,52 @@
               </a:defRPr>
             </a:pPr>
             <a:r>
-              <a:t>2. Perishable Inventory Crisis</a:t>
-            </a:r>
-          </a:p>
-          <a:p>
-            <a:pPr>
-              <a:spcBef>
-                <a:spcPts val="600"/>
-              </a:spcBef>
-              <a:defRPr sz="1100">
-                <a:solidFill>
-                  <a:srgbClr val="CBD5E1"/>
-                </a:solidFill>
-              </a:defRPr>
-            </a:pPr>
-            <a:r>
-              <a:t>• Hotels suffer from 30%+ average vacancy every night worldwide.</a:t>
-            </a:r>
-          </a:p>
-          <a:p>
-            <a:pPr>
-              <a:spcBef>
-                <a:spcPts val="600"/>
-              </a:spcBef>
-              <a:defRPr sz="1100">
-                <a:solidFill>
-                  <a:srgbClr val="CBD5E1"/>
-                </a:solidFill>
-              </a:defRPr>
-            </a:pPr>
-            <a:r>
-              <a:t>• Unsold rooms expire completely worthless at midnight.</a:t>
-            </a:r>
-          </a:p>
-          <a:p>
-            <a:pPr>
-              <a:spcBef>
-                <a:spcPts val="600"/>
-              </a:spcBef>
-              <a:defRPr sz="1100">
-                <a:solidFill>
-                  <a:srgbClr val="CBD5E1"/>
-                </a:solidFill>
-              </a:defRPr>
-            </a:pPr>
-            <a:r>
-              <a:t>• Hotels are contractually blocked from discounting publicly without debasing published brand rack rates.</a:t>
+              <a:t>2. The 'Price Parity' Trap</a:t>
+            </a:r>
+          </a:p>
+          <a:p>
+            <a:pPr>
+              <a:spcBef>
+                <a:spcPts val="600"/>
+              </a:spcBef>
+              <a:defRPr sz="1100">
+                <a:solidFill>
+                  <a:srgbClr val="CBD5E1"/>
+                </a:solidFill>
+              </a:defRPr>
+            </a:pPr>
+            <a:r>
+              <a:t>• Public OTAs enforce strict 'Price Parity' contracts: hotels are legally forbidden from advertising lower rates anywhere on the open web.</a:t>
+            </a:r>
+          </a:p>
+          <a:p>
+            <a:pPr>
+              <a:spcBef>
+                <a:spcPts val="600"/>
+              </a:spcBef>
+              <a:defRPr sz="1100">
+                <a:solidFill>
+                  <a:srgbClr val="CBD5E1"/>
+                </a:solidFill>
+              </a:defRPr>
+            </a:pPr>
+            <a:r>
+              <a:t>• If a hotel discounts on its own website or Google, OTAs penalize and bury them in search rankings.</a:t>
+            </a:r>
+          </a:p>
+          <a:p>
+            <a:pPr>
+              <a:spcBef>
+                <a:spcPts val="600"/>
+              </a:spcBef>
+              <a:defRPr sz="1100">
+                <a:solidFill>
+                  <a:srgbClr val="CBD5E1"/>
+                </a:solidFill>
+              </a:defRPr>
+            </a:pPr>
+            <a:r>
+              <a:t>• Hotels suffer from 30%+ perishable vacancies but cannot publicly discount without breaching contracts.</a:t>
             </a:r>
           </a:p>
         </p:txBody>
@@ -4806,52 +4806,52 @@
               </a:defRPr>
             </a:pPr>
             <a:r>
-              <a:t>Password-Gated Club</a:t>
-            </a:r>
-          </a:p>
-          <a:p>
-            <a:pPr>
-              <a:spcBef>
-                <a:spcPts val="600"/>
-              </a:spcBef>
-              <a:defRPr sz="1100">
-                <a:solidFill>
-                  <a:srgbClr val="CBD5E1"/>
-                </a:solidFill>
-              </a:defRPr>
-            </a:pPr>
-            <a:r>
-              <a:t>• Operates as an exclusive, private members' travel club.</a:t>
-            </a:r>
-          </a:p>
-          <a:p>
-            <a:pPr>
-              <a:spcBef>
-                <a:spcPts val="600"/>
-              </a:spcBef>
-              <a:defRPr sz="1100">
-                <a:solidFill>
-                  <a:srgbClr val="CBD5E1"/>
-                </a:solidFill>
-              </a:defRPr>
-            </a:pPr>
-            <a:r>
-              <a:t>• Statutory safe harbor under US Sherman Act § 1 and EU Digital Markets Act (DMA).</a:t>
-            </a:r>
-          </a:p>
-          <a:p>
-            <a:pPr>
-              <a:spcBef>
-                <a:spcPts val="600"/>
-              </a:spcBef>
-              <a:defRPr sz="1100">
-                <a:solidFill>
-                  <a:srgbClr val="CBD5E1"/>
-                </a:solidFill>
-              </a:defRPr>
-            </a:pPr>
-            <a:r>
-              <a:t>• Hotels eagerly provide 30%–50% net rates because pricing is hidden behind a paid login.</a:t>
+              <a:t>Closed-Loop Parity Exemption</a:t>
+            </a:r>
+          </a:p>
+          <a:p>
+            <a:pPr>
+              <a:spcBef>
+                <a:spcPts val="600"/>
+              </a:spcBef>
+              <a:defRPr sz="1100">
+                <a:solidFill>
+                  <a:srgbClr val="CBD5E1"/>
+                </a:solidFill>
+              </a:defRPr>
+            </a:pPr>
+            <a:r>
+              <a:t>• Price Parity clauses apply strictly to open, search-indexed public websites.</a:t>
+            </a:r>
+          </a:p>
+          <a:p>
+            <a:pPr>
+              <a:spcBef>
+                <a:spcPts val="600"/>
+              </a:spcBef>
+              <a:defRPr sz="1100">
+                <a:solidFill>
+                  <a:srgbClr val="CBD5E1"/>
+                </a:solidFill>
+              </a:defRPr>
+            </a:pPr>
+            <a:r>
+              <a:t>• Paid, password-gated clubs are 100% legally exempt under US Sherman Act § 1 and EU Digital Markets Act (DMA).</a:t>
+            </a:r>
+          </a:p>
+          <a:p>
+            <a:pPr>
+              <a:spcBef>
+                <a:spcPts val="600"/>
+              </a:spcBef>
+              <a:defRPr sz="1100">
+                <a:solidFill>
+                  <a:srgbClr val="CBD5E1"/>
+                </a:solidFill>
+              </a:defRPr>
+            </a:pPr>
+            <a:r>
+              <a:t>• Hotels eagerly release surplus rooms at 30%–50% discounts behind our private login without breaching OTA contracts.</a:t>
             </a:r>
           </a:p>
         </p:txBody>

</xml_diff>